<commit_message>
Updated Queries and added summaries, future prospects for ppt
</commit_message>
<xml_diff>
--- a/Team Amaan Presents.pptx
+++ b/Team Amaan Presents.pptx
@@ -226,7 +226,7 @@
           <a:p>
             <a:fld id="{B56F32FC-4BD9-442A-A8C6-51598C909FE3}" type="datetimeFigureOut">
               <a:rPr lang="en-US" smtClean="0"/>
-              <a:t>5/8/2026</a:t>
+              <a:t>5/9/2026</a:t>
             </a:fld>
             <a:endParaRPr lang="en-US" dirty="0"/>
           </a:p>
@@ -403,7 +403,7 @@
           <a:p>
             <a:fld id="{056371FA-A98D-41E8-93F4-09945841298A}" type="datetimeFigureOut">
               <a:rPr lang="en-US" smtClean="0"/>
-              <a:t>5/8/2026</a:t>
+              <a:t>5/9/2026</a:t>
             </a:fld>
             <a:endParaRPr lang="en-US" dirty="0"/>
           </a:p>
@@ -6861,31 +6861,6 @@
       </p:sp>
       <p:sp>
         <p:nvSpPr>
-          <p:cNvPr id="6" name="Text Placeholder 5">
-            <a:extLst>
-              <a:ext uri="{FF2B5EF4-FFF2-40B4-BE49-F238E27FC236}">
-                <a16:creationId xmlns:a16="http://schemas.microsoft.com/office/drawing/2014/main" id="{C61CA0EF-192C-A468-9A6D-58F30EA65412}"/>
-              </a:ext>
-            </a:extLst>
-          </p:cNvPr>
-          <p:cNvSpPr>
-            <a:spLocks noGrp="1"/>
-          </p:cNvSpPr>
-          <p:nvPr>
-            <p:ph type="body" idx="1"/>
-          </p:nvPr>
-        </p:nvSpPr>
-        <p:spPr/>
-        <p:txBody>
-          <a:bodyPr/>
-          <a:lstStyle/>
-          <a:p>
-            <a:endParaRPr lang="en-US"/>
-          </a:p>
-        </p:txBody>
-      </p:sp>
-      <p:sp>
-        <p:nvSpPr>
           <p:cNvPr id="7" name="Content Placeholder 6">
             <a:extLst>
               <a:ext uri="{FF2B5EF4-FFF2-40B4-BE49-F238E27FC236}">
@@ -6900,12 +6875,32 @@
             <p:ph sz="half" idx="2"/>
           </p:nvPr>
         </p:nvSpPr>
-        <p:spPr/>
+        <p:spPr>
+          <a:xfrm>
+            <a:off x="838199" y="2445026"/>
+            <a:ext cx="5733773" cy="3741873"/>
+          </a:xfrm>
+        </p:spPr>
         <p:txBody>
           <a:bodyPr/>
           <a:lstStyle/>
           <a:p>
-            <a:endParaRPr lang="en-US"/>
+            <a:r>
+              <a:rPr lang="en-US" dirty="0"/>
+              <a:t>Via utilizing Python, we have created a two - part query processing system</a:t>
+            </a:r>
+          </a:p>
+          <a:p>
+            <a:r>
+              <a:rPr lang="en-US" dirty="0"/>
+              <a:t>First part takes user input of a given form and stores it in a normalized format after validation checks have been set</a:t>
+            </a:r>
+          </a:p>
+          <a:p>
+            <a:r>
+              <a:rPr lang="en-US" dirty="0"/>
+              <a:t>Second part processes the normalized tokens to output a table of values as specified by the input</a:t>
+            </a:r>
           </a:p>
         </p:txBody>
       </p:sp>
@@ -6925,9 +6920,16 @@
             <p:ph sz="half" idx="14"/>
           </p:nvPr>
         </p:nvSpPr>
-        <p:spPr/>
-        <p:txBody>
-          <a:bodyPr/>
+        <p:spPr>
+          <a:xfrm>
+            <a:off x="7580243" y="2981739"/>
+            <a:ext cx="4250491" cy="3374611"/>
+          </a:xfrm>
+        </p:spPr>
+        <p:txBody>
+          <a:bodyPr>
+            <a:normAutofit fontScale="77500" lnSpcReduction="20000"/>
+          </a:bodyPr>
           <a:lstStyle/>
           <a:p>
             <a:r>
@@ -6940,7 +6942,58 @@
               <a:buFont typeface="Arial" panose="020B0604020202020204" pitchFamily="34" charset="0"/>
               <a:buChar char="•"/>
             </a:pPr>
-            <a:endParaRPr lang="en-US" dirty="0"/>
+            <a:r>
+              <a:rPr lang="en-US" dirty="0"/>
+              <a:t>Support for more complex HAVING conditions with nested logic and parentheses</a:t>
+            </a:r>
+          </a:p>
+          <a:p>
+            <a:pPr marL="285750" indent="-285750">
+              <a:buFont typeface="Arial" panose="020B0604020202020204" pitchFamily="34" charset="0"/>
+              <a:buChar char="•"/>
+            </a:pPr>
+            <a:r>
+              <a:rPr lang="en-US" dirty="0"/>
+              <a:t>Ability to export query results to CSV or another structured output format</a:t>
+            </a:r>
+          </a:p>
+          <a:p>
+            <a:pPr marL="285750" indent="-285750">
+              <a:buFont typeface="Arial" panose="020B0604020202020204" pitchFamily="34" charset="0"/>
+              <a:buChar char="•"/>
+            </a:pPr>
+            <a:r>
+              <a:rPr lang="en-US" dirty="0"/>
+              <a:t>A graphical or web-based interface for entering </a:t>
+            </a:r>
+            <a:r>
+              <a:rPr lang="en-US" dirty="0" err="1"/>
+              <a:t>MFQuery</a:t>
+            </a:r>
+            <a:r>
+              <a:rPr lang="en-US" dirty="0"/>
+              <a:t> input instead of plain text</a:t>
+            </a:r>
+          </a:p>
+          <a:p>
+            <a:pPr marL="285750" indent="-285750">
+              <a:buFont typeface="Arial" panose="020B0604020202020204" pitchFamily="34" charset="0"/>
+              <a:buChar char="•"/>
+            </a:pPr>
+            <a:r>
+              <a:rPr lang="en-US" dirty="0"/>
+              <a:t>Implementation of parallel processing to evaluate multiple grouping variables and aggregate calculations simultaneously.</a:t>
+            </a:r>
+          </a:p>
+          <a:p>
+            <a:pPr marL="285750" indent="-285750">
+              <a:buFont typeface="Arial" panose="020B0604020202020204" pitchFamily="34" charset="0"/>
+              <a:buChar char="•"/>
+            </a:pPr>
+            <a:r>
+              <a:rPr lang="en-US" dirty="0"/>
+              <a:t>Serializability checks to ensure that parallel query operations produce consistent and correct results.</a:t>
+            </a:r>
           </a:p>
         </p:txBody>
       </p:sp>
@@ -11831,6 +11884,15 @@
 </file>
 
 <file path=customXml/item1.xml><?xml version="1.0" encoding="utf-8"?>
+<?mso-contentType ?>
+<FormTemplates xmlns="http://schemas.microsoft.com/sharepoint/v3/contenttype/forms">
+  <Display>DocumentLibraryForm</Display>
+  <Edit>DocumentLibraryForm</Edit>
+  <New>DocumentLibraryForm</New>
+</FormTemplates>
+</file>
+
+<file path=customXml/item2.xml><?xml version="1.0" encoding="utf-8"?>
 <ct:contentTypeSchema xmlns:ct="http://schemas.microsoft.com/office/2006/metadata/contentType" xmlns:ma="http://schemas.microsoft.com/office/2006/metadata/properties/metaAttributes" ct:_="" ma:_="" ma:contentTypeName="Document" ma:contentTypeID="0x01010079F111ED35F8CC479449609E8A0923A6" ma:contentTypeVersion="28" ma:contentTypeDescription="Create a new document." ma:contentTypeScope="" ma:versionID="60f5a4f2d2b0abadcf532d48ebf9cb71">
   <xsd:schema xmlns:xsd="http://www.w3.org/2001/XMLSchema" xmlns:xs="http://www.w3.org/2001/XMLSchema" xmlns:p="http://schemas.microsoft.com/office/2006/metadata/properties" xmlns:ns1="http://schemas.microsoft.com/sharepoint/v3" xmlns:ns2="71af3243-3dd4-4a8d-8c0d-dd76da1f02a5" xmlns:ns3="16c05727-aa75-4e4a-9b5f-8a80a1165891" xmlns:ns4="230e9df3-be65-4c73-a93b-d1236ebd677e" targetNamespace="http://schemas.microsoft.com/office/2006/metadata/properties" ma:root="true" ma:fieldsID="7dd78129e6a1811f84807ad11c651531" ns1:_="" ns2:_="" ns3:_="" ns4:_="">
     <xsd:import namespace="http://schemas.microsoft.com/sharepoint/v3"/>
@@ -12142,15 +12204,6 @@
 </ct:contentTypeSchema>
 </file>
 
-<file path=customXml/item2.xml><?xml version="1.0" encoding="utf-8"?>
-<?mso-contentType ?>
-<FormTemplates xmlns="http://schemas.microsoft.com/sharepoint/v3/contenttype/forms">
-  <Display>DocumentLibraryForm</Display>
-  <Edit>DocumentLibraryForm</Edit>
-  <New>DocumentLibraryForm</New>
-</FormTemplates>
-</file>
-
 <file path=customXml/item3.xml><?xml version="1.0" encoding="utf-8"?>
 <p:properties xmlns:p="http://schemas.microsoft.com/office/2006/metadata/properties" xmlns:xsi="http://www.w3.org/2001/XMLSchema-instance" xmlns:pc="http://schemas.microsoft.com/office/infopath/2007/PartnerControls">
   <documentManagement>
@@ -12172,6 +12225,14 @@
 </file>
 
 <file path=customXml/itemProps1.xml><?xml version="1.0" encoding="utf-8"?>
+<ds:datastoreItem xmlns:ds="http://schemas.openxmlformats.org/officeDocument/2006/customXml" ds:itemID="{CABF691C-888B-4061-8A6F-D5CE84A0254B}">
+  <ds:schemaRefs>
+    <ds:schemaRef ds:uri="http://schemas.microsoft.com/sharepoint/v3/contenttype/forms"/>
+  </ds:schemaRefs>
+</ds:datastoreItem>
+</file>
+
+<file path=customXml/itemProps2.xml><?xml version="1.0" encoding="utf-8"?>
 <ds:datastoreItem xmlns:ds="http://schemas.openxmlformats.org/officeDocument/2006/customXml" ds:itemID="{5EDE3176-A15D-46A3-BDDB-64A0D7363224}">
   <ds:schemaRefs>
     <ds:schemaRef ds:uri="http://schemas.microsoft.com/office/2006/metadata/contentType"/>
@@ -12192,14 +12253,6 @@
 </ds:datastoreItem>
 </file>
 
-<file path=customXml/itemProps2.xml><?xml version="1.0" encoding="utf-8"?>
-<ds:datastoreItem xmlns:ds="http://schemas.openxmlformats.org/officeDocument/2006/customXml" ds:itemID="{CABF691C-888B-4061-8A6F-D5CE84A0254B}">
-  <ds:schemaRefs>
-    <ds:schemaRef ds:uri="http://schemas.microsoft.com/sharepoint/v3/contenttype/forms"/>
-  </ds:schemaRefs>
-</ds:datastoreItem>
-</file>
-
 <file path=customXml/itemProps3.xml><?xml version="1.0" encoding="utf-8"?>
 <ds:datastoreItem xmlns:ds="http://schemas.openxmlformats.org/officeDocument/2006/customXml" ds:itemID="{49168DCE-134F-4610-A6AA-88CEBE8D71D2}">
   <ds:schemaRefs>

</xml_diff>